<commit_message>
docs: resultados del retenido v3, presentacion y guiones del video de la entrega
</commit_message>
<xml_diff>
--- a/presidencia/entrega/LATAM_Bank_Factored_Hackathon_2026.pptx
+++ b/presidencia/entrega/LATAM_Bank_Factored_Hackathon_2026.pptx
@@ -825,7 +825,7 @@
     <c:plotArea>
       <c:layout/>
       <c:barChart>
-        <c:barDir val="bar"/>
+        <c:barDir val="col"/>
         <c:grouping val="clustered"/>
         <c:varyColors val="0"/>
         <c:ser>
@@ -837,7 +837,84 @@
               <c:strCache>
                 <c:ptCount val="1"/>
                 <c:pt idx="0">
-                  <c:v>Runs passing every check</c:v>
+                  <c:v>AI agent</c:v>
+                </c:pt>
+              </c:strCache>
+            </c:strRef>
+          </c:tx>
+          <c:spPr>
+            <a:solidFill>
+              <a:srgbClr val="0B6E4F"/>
+            </a:solidFill>
+            <a:effectLst/>
+          </c:spPr>
+          <c:invertIfNegative val="0"/>
+          <c:dLbls>
+            <c:numFmt formatCode="#,##0" sourceLinked="0"/>
+            <c:txPr>
+              <a:bodyPr/>
+              <a:lstStyle/>
+              <a:p>
+                <a:pPr>
+                  <a:defRPr b="0" i="0" strike="noStrike" sz="1300" u="none">
+                    <a:solidFill>
+                      <a:srgbClr val="0B1F2A"/>
+                    </a:solidFill>
+                    <a:latin typeface="Calibri"/>
+                  </a:defRPr>
+                </a:pPr>
+              </a:p>
+            </c:txPr>
+            <c:showLegendKey val="0"/>
+            <c:showVal val="1"/>
+            <c:showCatName val="0"/>
+            <c:showSerName val="0"/>
+            <c:showPercent val="0"/>
+            <c:showBubbleSize val="0"/>
+            <c:showLeaderLines val="0"/>
+          </c:dLbls>
+          <c:cat>
+            <c:multiLvlStrRef>
+              <c:f>Sheet1!$A$2:$A$3</c:f>
+              <c:multiLvlStrCache>
+                <c:ptCount val="2"/>
+                <c:lvl>
+                  <c:pt idx="0">
+                    <c:v>Dispute flow (30 cases)</c:v>
+                  </c:pt>
+                  <c:pt idx="1">
+                    <c:v>Policy, follow-up, multi-request (13)</c:v>
+                  </c:pt>
+                </c:lvl>
+              </c:multiLvlStrCache>
+            </c:multiLvlStrRef>
+          </c:cat>
+          <c:val>
+            <c:numRef>
+              <c:f>Sheet1!$B$2:$B$3</c:f>
+              <c:numCache>
+                <c:formatCode>General</c:formatCode>
+                <c:ptCount val="2"/>
+                <c:pt idx="0">
+                  <c:v>92</c:v>
+                </c:pt>
+                <c:pt idx="1">
+                  <c:v>82</c:v>
+                </c:pt>
+              </c:numCache>
+            </c:numRef>
+          </c:val>
+        </c:ser>
+        <c:ser>
+          <c:idx val="1"/>
+          <c:order val="1"/>
+          <c:tx>
+            <c:strRef>
+              <c:f>Sheet1!$C$1</c:f>
+              <c:strCache>
+                <c:ptCount val="1"/>
+                <c:pt idx="0">
+                  <c:v>Rules baseline</c:v>
                 </c:pt>
               </c:strCache>
             </c:strRef>
@@ -873,28 +950,6 @@
             <c:showBubbleSize val="0"/>
             <c:showLeaderLines val="0"/>
           </c:dLbls>
-          <c:dPt>
-            <c:idx val="0"/>
-            <c:invertIfNegative val="0"/>
-            <c:bubble3D val="0"/>
-            <c:spPr>
-              <a:solidFill>
-                <a:srgbClr val="C9D3D0"/>
-              </a:solidFill>
-              <a:effectLst/>
-            </c:spPr>
-          </c:dPt>
-          <c:dPt>
-            <c:idx val="1"/>
-            <c:invertIfNegative val="0"/>
-            <c:bubble3D val="0"/>
-            <c:spPr>
-              <a:solidFill>
-                <a:srgbClr val="0B6E4F"/>
-              </a:solidFill>
-              <a:effectLst/>
-            </c:spPr>
-          </c:dPt>
           <c:cat>
             <c:multiLvlStrRef>
               <c:f>Sheet1!$A$2:$A$3</c:f>
@@ -902,10 +957,10 @@
                 <c:ptCount val="2"/>
                 <c:lvl>
                   <c:pt idx="0">
-                    <c:v>Rules baseline</c:v>
+                    <c:v>Dispute flow (30 cases)</c:v>
                   </c:pt>
                   <c:pt idx="1">
-                    <c:v>AI agent</c:v>
+                    <c:v>Policy, follow-up, multi-request (13)</c:v>
                   </c:pt>
                 </c:lvl>
               </c:multiLvlStrCache>
@@ -913,15 +968,15 @@
           </c:cat>
           <c:val>
             <c:numRef>
-              <c:f>Sheet1!$B$2:$B$3</c:f>
+              <c:f>Sheet1!$C$2:$C$3</c:f>
               <c:numCache>
                 <c:formatCode>General</c:formatCode>
                 <c:ptCount val="2"/>
                 <c:pt idx="0">
-                  <c:v>91</c:v>
+                  <c:v>87</c:v>
                 </c:pt>
                 <c:pt idx="1">
-                  <c:v>80</c:v>
+                  <c:v>38</c:v>
                 </c:pt>
               </c:numCache>
             </c:numRef>
@@ -951,7 +1006,7 @@
           <c:showBubbleSize val="0"/>
           <c:showLeaderLines val="0"/>
         </c:dLbls>
-        <c:gapWidth val="50"/>
+        <c:gapWidth val="60"/>
         <c:overlap val="0"/>
         <c:axId val="2094734554"/>
         <c:axId val="2094734552"/>
@@ -963,8 +1018,50 @@
           <c:orientation val="minMax"/>
         </c:scaling>
         <c:delete val="0"/>
+        <c:axPos val="b"/>
+        <c:numFmt formatCode="General" sourceLinked="1"/>
+        <c:majorTickMark val="out"/>
+        <c:minorTickMark val="none"/>
+        <c:tickLblPos val="low"/>
+        <c:spPr>
+          <a:ln w="12700" cap="flat">
+            <a:solidFill>
+              <a:srgbClr val="888888"/>
+            </a:solidFill>
+            <a:prstDash val="solid"/>
+            <a:round/>
+          </a:ln>
+        </c:spPr>
+        <c:txPr>
+          <a:bodyPr/>
+          <a:lstStyle/>
+          <a:p>
+            <a:pPr>
+              <a:defRPr sz="1200" b="0" i="0" u="none" strike="noStrike">
+                <a:solidFill>
+                  <a:srgbClr val="0B1F2A"/>
+                </a:solidFill>
+                <a:latin typeface="Calibri"/>
+              </a:defRPr>
+            </a:pPr>
+            <a:endParaRPr lang="en-US"/>
+          </a:p>
+        </c:txPr>
+        <c:crossAx val="2094734552"/>
+        <c:crosses val="autoZero"/>
+        <c:auto val="1"/>
+        <c:lblAlgn val="ctr"/>
+        <c:noMultiLvlLbl val="1"/>
+      </c:catAx>
+      <c:valAx>
+        <c:axId val="2094734552"/>
+        <c:scaling>
+          <c:orientation val="minMax"/>
+          <c:max val="110"/>
+        </c:scaling>
+        <c:delete val="1"/>
         <c:axPos val="l"/>
-        <c:numFmt formatCode="General" sourceLinked="1"/>
+        <c:numFmt formatCode="General" sourceLinked="0"/>
         <c:majorTickMark val="out"/>
         <c:minorTickMark val="none"/>
         <c:tickLblPos val="nextTo"/>
@@ -982,48 +1079,6 @@
           <a:lstStyle/>
           <a:p>
             <a:pPr>
-              <a:defRPr sz="1300" b="0" i="0" u="none" strike="noStrike">
-                <a:solidFill>
-                  <a:srgbClr val="0B1F2A"/>
-                </a:solidFill>
-                <a:latin typeface="Calibri"/>
-              </a:defRPr>
-            </a:pPr>
-            <a:endParaRPr lang="en-US"/>
-          </a:p>
-        </c:txPr>
-        <c:crossAx val="2094734552"/>
-        <c:crosses val="autoZero"/>
-        <c:auto val="1"/>
-        <c:lblAlgn val="ctr"/>
-        <c:noMultiLvlLbl val="1"/>
-      </c:catAx>
-      <c:valAx>
-        <c:axId val="2094734552"/>
-        <c:scaling>
-          <c:orientation val="minMax"/>
-          <c:max val="110"/>
-        </c:scaling>
-        <c:delete val="1"/>
-        <c:axPos val="b"/>
-        <c:numFmt formatCode="General" sourceLinked="0"/>
-        <c:majorTickMark val="out"/>
-        <c:minorTickMark val="none"/>
-        <c:tickLblPos val="low"/>
-        <c:spPr>
-          <a:ln w="12700" cap="flat">
-            <a:solidFill>
-              <a:srgbClr val="888888"/>
-            </a:solidFill>
-            <a:prstDash val="solid"/>
-            <a:round/>
-          </a:ln>
-        </c:spPr>
-        <c:txPr>
-          <a:bodyPr/>
-          <a:lstStyle/>
-          <a:p>
-            <a:pPr>
               <a:defRPr sz="1200" b="0" i="0" u="none" strike="noStrike">
                 <a:solidFill>
                   <a:srgbClr val="000000"/>
@@ -1046,6 +1101,26 @@
         <a:effectLst/>
       </c:spPr>
     </c:plotArea>
+    <c:legend>
+      <c:legendPos val="t"/>
+      <c:overlay val="0"/>
+      <c:txPr>
+        <a:bodyPr/>
+        <a:lstStyle/>
+        <a:p>
+          <a:pPr>
+            <a:defRPr sz="1200">
+              <a:solidFill>
+                <a:srgbClr val="0B1F2A"/>
+              </a:solidFill>
+              <a:latin typeface="Calibri"/>
+              <a:cs typeface="Calibri"/>
+            </a:defRPr>
+          </a:pPr>
+          <a:endParaRPr lang="en-US"/>
+        </a:p>
+      </c:txPr>
+    </c:legend>
     <c:plotVisOnly val="1"/>
     <c:dispBlanksAs val="span"/>
   </c:chart>
@@ -6320,7 +6395,7 @@
                 <a:ea typeface="Calibri" pitchFamily="34" charset="-122"/>
                 <a:cs typeface="Calibri" pitchFamily="34" charset="-120"/>
               </a:rPr>
-              <a:t>Zero unsafe outcomes in 96 runs, and an honest baseline</a:t>
+              <a:t>On a fresh held-out set, the agent beats the rules baseline</a:t>
             </a:r>
             <a:endParaRPr lang="en-US" sz="3200" dirty="0"/>
           </a:p>
@@ -6386,7 +6461,7 @@
                 <a:ea typeface="Calibri" pitchFamily="34" charset="-122"/>
                 <a:cs typeface="Calibri" pitchFamily="34" charset="-120"/>
               </a:rPr>
-              <a:t>0 / 96</a:t>
+              <a:t>89%</a:t>
             </a:r>
             <a:endParaRPr lang="en-US" sz="4400" dirty="0"/>
           </a:p>
@@ -6425,7 +6500,7 @@
                 <a:ea typeface="Calibri" pitchFamily="34" charset="-122"/>
                 <a:cs typeface="Calibri" pitchFamily="34" charset="-120"/>
               </a:rPr>
-              <a:t>unsafe outcomes. Bounds the risk at 4%, does not prove zero</a:t>
+              <a:t>of 129 runs pass every check. 43 new cases, frozen before building</a:t>
             </a:r>
             <a:endParaRPr lang="en-US" sz="1400" dirty="0"/>
           </a:p>
@@ -6491,7 +6566,7 @@
                 <a:ea typeface="Calibri" pitchFamily="34" charset="-122"/>
                 <a:cs typeface="Calibri" pitchFamily="34" charset="-120"/>
               </a:rPr>
-              <a:t>81%</a:t>
+              <a:t>82%</a:t>
             </a:r>
             <a:endParaRPr lang="en-US" sz="4400" dirty="0"/>
           </a:p>
@@ -6530,7 +6605,7 @@
                 <a:ea typeface="Calibri" pitchFamily="34" charset="-122"/>
                 <a:cs typeface="Calibri" pitchFamily="34" charset="-120"/>
               </a:rPr>
-              <a:t>safe automated resolution on resolvable cases (29 of 36)</a:t>
+              <a:t>safe automated resolution on resolvable cases. Rules: 62%</a:t>
             </a:r>
             <a:endParaRPr lang="en-US" sz="1400" dirty="0"/>
           </a:p>
@@ -6596,7 +6671,7 @@
                 <a:ea typeface="Calibri" pitchFamily="34" charset="-122"/>
                 <a:cs typeface="Calibri" pitchFamily="34" charset="-120"/>
               </a:rPr>
-              <a:t>1.4 s</a:t>
+              <a:t>0 / 18</a:t>
             </a:r>
             <a:endParaRPr lang="en-US" sz="4400" dirty="0"/>
           </a:p>
@@ -6635,7 +6710,7 @@
                 <a:ea typeface="Calibri" pitchFamily="34" charset="-122"/>
                 <a:cs typeface="Calibri" pitchFamily="34" charset="-120"/>
               </a:rPr>
-              <a:t>median agent turn. p95 4.6 s</a:t>
+              <a:t>missed handoffs to a human</a:t>
             </a:r>
             <a:endParaRPr lang="en-US" sz="1400" dirty="0"/>
           </a:p>
@@ -6695,13 +6770,13 @@
             <a:r>
               <a:rPr lang="en-US" sz="4400" b="1" dirty="0">
                 <a:solidFill>
-                  <a:srgbClr val="0B6E4F"/>
-                </a:solidFill>
-                <a:latin typeface="Calibri" pitchFamily="34" charset="0"/>
-                <a:ea typeface="Calibri" pitchFamily="34" charset="-122"/>
-                <a:cs typeface="Calibri" pitchFamily="34" charset="-120"/>
-              </a:rPr>
-              <a:t>$0.002</a:t>
+                  <a:srgbClr val="B5483A"/>
+                </a:solidFill>
+                <a:latin typeface="Calibri" pitchFamily="34" charset="0"/>
+                <a:ea typeface="Calibri" pitchFamily="34" charset="-122"/>
+                <a:cs typeface="Calibri" pitchFamily="34" charset="-120"/>
+              </a:rPr>
+              <a:t>1 / 129</a:t>
             </a:r>
             <a:endParaRPr lang="en-US" sz="4400" dirty="0"/>
           </a:p>
@@ -6740,7 +6815,7 @@
                 <a:ea typeface="Calibri" pitchFamily="34" charset="-122"/>
                 <a:cs typeface="Calibri" pitchFamily="34" charset="-120"/>
               </a:rPr>
-              <a:t>model cost per attempted case</a:t>
+              <a:t>real unsafe outcome (echoed typed card digits). 3 more flags: fixture artifact</a:t>
             </a:r>
             <a:endParaRPr lang="en-US" sz="1400" dirty="0"/>
           </a:p>
@@ -6753,8 +6828,8 @@
           <p:nvPr/>
         </p:nvGraphicFramePr>
         <p:xfrm>
-          <a:off x="457200" y="3520440"/>
-          <a:ext cx="5120640" cy="2697480"/>
+          <a:off x="457200" y="3474720"/>
+          <a:ext cx="6035040" cy="2788920"/>
         </p:xfrm>
         <a:graphic xmlns:a="http://schemas.openxmlformats.org/drawingml/2006/main">
           <a:graphicData uri="http://schemas.openxmlformats.org/drawingml/2006/chart">
@@ -6770,8 +6845,8 @@
         </p:nvSpPr>
         <p:spPr>
           <a:xfrm>
-            <a:off x="5943600" y="3611880"/>
-            <a:ext cx="5669280" cy="914400"/>
+            <a:off x="6858000" y="3566160"/>
+            <a:ext cx="4754880" cy="960120"/>
           </a:xfrm>
           <a:prstGeom prst="rect">
             <a:avLst/>
@@ -6795,7 +6870,7 @@
                 <a:ea typeface="Calibri" pitchFamily="34" charset="-122"/>
                 <a:cs typeface="Calibri" pitchFamily="34" charset="-120"/>
               </a:rPr>
-              <a:t>Rules follow policy as well as the agent. The agent adds language, conversation and coverage. Four defects found, fixed in the tool layer.</a:t>
+              <a:t>Rules tie on the core flow. The agent wins where rules cannot go. On an older set and version, rules led 91 to 80, with 0 of 96 unsafe.</a:t>
             </a:r>
             <a:endParaRPr lang="en-US" sz="1450" dirty="0"/>
           </a:p>
@@ -6809,8 +6884,8 @@
         </p:nvSpPr>
         <p:spPr>
           <a:xfrm>
-            <a:off x="5943600" y="4709160"/>
-            <a:ext cx="457200" cy="457200"/>
+            <a:off x="6858000" y="4617720"/>
+            <a:ext cx="402336" cy="402336"/>
           </a:xfrm>
           <a:prstGeom prst="ellipse">
             <a:avLst/>
@@ -6842,8 +6917,8 @@
         </p:blipFill>
         <p:spPr>
           <a:xfrm>
-            <a:off x="6062472" y="4828032"/>
-            <a:ext cx="219456" cy="219456"/>
+            <a:off x="6962607" y="4722327"/>
+            <a:ext cx="193121" cy="193121"/>
           </a:xfrm>
           <a:prstGeom prst="rect">
             <a:avLst/>
@@ -6858,8 +6933,8 @@
         </p:nvSpPr>
         <p:spPr>
           <a:xfrm>
-            <a:off x="6492240" y="4736592"/>
-            <a:ext cx="1325880" cy="457200"/>
+            <a:off x="7360920" y="4636008"/>
+            <a:ext cx="1874520" cy="384048"/>
           </a:xfrm>
           <a:prstGeom prst="rect">
             <a:avLst/>
@@ -6897,8 +6972,8 @@
         </p:nvSpPr>
         <p:spPr>
           <a:xfrm>
-            <a:off x="7863840" y="4709160"/>
-            <a:ext cx="457200" cy="457200"/>
+            <a:off x="9326880" y="4617720"/>
+            <a:ext cx="402336" cy="402336"/>
           </a:xfrm>
           <a:prstGeom prst="ellipse">
             <a:avLst/>
@@ -6930,8 +7005,8 @@
         </p:blipFill>
         <p:spPr>
           <a:xfrm>
-            <a:off x="7982712" y="4828032"/>
-            <a:ext cx="219456" cy="219456"/>
+            <a:off x="9431487" y="4722327"/>
+            <a:ext cx="193121" cy="193121"/>
           </a:xfrm>
           <a:prstGeom prst="rect">
             <a:avLst/>
@@ -6946,8 +7021,8 @@
         </p:nvSpPr>
         <p:spPr>
           <a:xfrm>
-            <a:off x="8412480" y="4736592"/>
-            <a:ext cx="1325880" cy="457200"/>
+            <a:off x="9829800" y="4636008"/>
+            <a:ext cx="1874520" cy="384048"/>
           </a:xfrm>
           <a:prstGeom prst="rect">
             <a:avLst/>
@@ -6985,8 +7060,8 @@
         </p:nvSpPr>
         <p:spPr>
           <a:xfrm>
-            <a:off x="9784080" y="4709160"/>
-            <a:ext cx="457200" cy="457200"/>
+            <a:off x="6858000" y="5166360"/>
+            <a:ext cx="402336" cy="402336"/>
           </a:xfrm>
           <a:prstGeom prst="ellipse">
             <a:avLst/>
@@ -7018,8 +7093,8 @@
         </p:blipFill>
         <p:spPr>
           <a:xfrm>
-            <a:off x="9902952" y="4828032"/>
-            <a:ext cx="219456" cy="219456"/>
+            <a:off x="6962607" y="5270967"/>
+            <a:ext cx="193121" cy="193121"/>
           </a:xfrm>
           <a:prstGeom prst="rect">
             <a:avLst/>
@@ -7034,8 +7109,8 @@
         </p:nvSpPr>
         <p:spPr>
           <a:xfrm>
-            <a:off x="10332720" y="4736592"/>
-            <a:ext cx="1325880" cy="457200"/>
+            <a:off x="7360920" y="5184648"/>
+            <a:ext cx="1874520" cy="384048"/>
           </a:xfrm>
           <a:prstGeom prst="rect">
             <a:avLst/>
@@ -7073,8 +7148,8 @@
         </p:nvSpPr>
         <p:spPr>
           <a:xfrm>
-            <a:off x="5943600" y="5458968"/>
-            <a:ext cx="457200" cy="457200"/>
+            <a:off x="9326880" y="5166360"/>
+            <a:ext cx="402336" cy="402336"/>
           </a:xfrm>
           <a:prstGeom prst="ellipse">
             <a:avLst/>
@@ -7106,8 +7181,8 @@
         </p:blipFill>
         <p:spPr>
           <a:xfrm>
-            <a:off x="6062472" y="5577840"/>
-            <a:ext cx="219456" cy="219456"/>
+            <a:off x="9431487" y="5270967"/>
+            <a:ext cx="193121" cy="193121"/>
           </a:xfrm>
           <a:prstGeom prst="rect">
             <a:avLst/>
@@ -7122,8 +7197,8 @@
         </p:nvSpPr>
         <p:spPr>
           <a:xfrm>
-            <a:off x="6492240" y="5486400"/>
-            <a:ext cx="1325880" cy="457200"/>
+            <a:off x="9829800" y="5184648"/>
+            <a:ext cx="1874520" cy="384048"/>
           </a:xfrm>
           <a:prstGeom prst="rect">
             <a:avLst/>
@@ -7161,8 +7236,8 @@
         </p:nvSpPr>
         <p:spPr>
           <a:xfrm>
-            <a:off x="7863840" y="5458968"/>
-            <a:ext cx="457200" cy="457200"/>
+            <a:off x="6858000" y="5715000"/>
+            <a:ext cx="402336" cy="402336"/>
           </a:xfrm>
           <a:prstGeom prst="ellipse">
             <a:avLst/>
@@ -7194,8 +7269,8 @@
         </p:blipFill>
         <p:spPr>
           <a:xfrm>
-            <a:off x="7982712" y="5577840"/>
-            <a:ext cx="219456" cy="219456"/>
+            <a:off x="6962607" y="5819607"/>
+            <a:ext cx="193121" cy="193121"/>
           </a:xfrm>
           <a:prstGeom prst="rect">
             <a:avLst/>
@@ -7210,8 +7285,8 @@
         </p:nvSpPr>
         <p:spPr>
           <a:xfrm>
-            <a:off x="8412480" y="5486400"/>
-            <a:ext cx="1325880" cy="457200"/>
+            <a:off x="7360920" y="5733288"/>
+            <a:ext cx="1874520" cy="384048"/>
           </a:xfrm>
           <a:prstGeom prst="rect">
             <a:avLst/>
@@ -7249,8 +7324,8 @@
         </p:nvSpPr>
         <p:spPr>
           <a:xfrm>
-            <a:off x="9784080" y="5458968"/>
-            <a:ext cx="457200" cy="457200"/>
+            <a:off x="9326880" y="5715000"/>
+            <a:ext cx="402336" cy="402336"/>
           </a:xfrm>
           <a:prstGeom prst="ellipse">
             <a:avLst/>
@@ -7282,8 +7357,8 @@
         </p:blipFill>
         <p:spPr>
           <a:xfrm>
-            <a:off x="9902952" y="5577840"/>
-            <a:ext cx="219456" cy="219456"/>
+            <a:off x="9431487" y="5819607"/>
+            <a:ext cx="193121" cy="193121"/>
           </a:xfrm>
           <a:prstGeom prst="rect">
             <a:avLst/>
@@ -7298,8 +7373,8 @@
         </p:nvSpPr>
         <p:spPr>
           <a:xfrm>
-            <a:off x="10332720" y="5486400"/>
-            <a:ext cx="1325880" cy="457200"/>
+            <a:off x="9829800" y="5733288"/>
+            <a:ext cx="1874520" cy="384048"/>
           </a:xfrm>
           <a:prstGeom prst="rect">
             <a:avLst/>

</xml_diff>